<commit_message>
chore: 删除汇报PPT中GPS相关内容，替换为车辆状态监控 Co-authored-by: monkeycode-ai <monkeycode-ai@chaitin.com>
</commit_message>
<xml_diff>
--- a/公务用车管理信息系统-汇报方案.pptx
+++ b/公务用车管理信息系统-汇报方案.pptx
@@ -8528,7 +8528,7 @@
             </a:r>
             <a:br/>
             <a:r>
-              <a:t>全程GPS轨迹可查</a:t>
+              <a:t>全程行车记录可查</a:t>
             </a:r>
           </a:p>
         </p:txBody>
@@ -11643,7 +11643,7 @@
               </a:defRPr>
             </a:pPr>
             <a:r>
-              <a:t>GPS轨迹监控</a:t>
+              <a:t>车辆状态监控</a:t>
             </a:r>
           </a:p>
         </p:txBody>
@@ -11678,15 +11678,15 @@
               </a:defRPr>
             </a:pPr>
             <a:r>
-              <a:t>实时记录车辆行驶轨迹，支持</a:t>
+              <a:t>实时掌握车辆使用状态和位置，</a:t>
             </a:r>
             <a:br/>
             <a:r>
-              <a:t>轨迹回放和里程统计，异常行驶</a:t>
+              <a:t>空闲/出车/维修/停运一目了然，</a:t>
             </a:r>
             <a:br/>
             <a:r>
-              <a:t>自动告警，加强用车过程监管</a:t>
+              <a:t>异常状态自动提醒</a:t>
             </a:r>
           </a:p>
         </p:txBody>
@@ -17812,7 +17812,7 @@
               </a:defRPr>
             </a:pPr>
             <a:r>
-              <a:t>  GPS轨迹监控与电子围栏功能部署</a:t>
+              <a:t>  车辆状态实时监控功能部署</a:t>
             </a:r>
           </a:p>
         </p:txBody>

</xml_diff>

<commit_message>
chore: 删除汇报PPT中纪检监察和财务人员角色，8种→6种 Co-authored-by: monkeycode-ai <monkeycode-ai@chaitin.com>
</commit_message>
<xml_diff>
--- a/公务用车管理信息系统-汇报方案.pptx
+++ b/公务用车管理信息系统-汇报方案.pptx
@@ -4546,7 +4546,7 @@
               </a:defRPr>
             </a:pPr>
             <a:r>
-              <a:t>8</a:t>
+              <a:t>6</a:t>
             </a:r>
           </a:p>
         </p:txBody>
@@ -7307,7 +7307,7 @@
             </a:r>
             <a:br/>
             <a:r>
-              <a:t>调度员|司机|纪检|财务|分管领导</a:t>
+              <a:t>调度员|司机|分管领导</a:t>
             </a:r>
           </a:p>
         </p:txBody>
@@ -12650,11 +12650,11 @@
             </a:r>
             <a:br/>
             <a:r>
-              <a:t>调度员、驾驶员、纪检监察、</a:t>
+              <a:t>调度员、驾驶员、</a:t>
             </a:r>
             <a:br/>
             <a:r>
-              <a:t>财务、分管领导等8种固化角色</a:t>
+              <a:t>分管领导等6种固化角色</a:t>
             </a:r>
           </a:p>
         </p:txBody>
@@ -13070,7 +13070,7 @@
               </a:defRPr>
             </a:pPr>
             <a:r>
-              <a:t>8种固化角色，各司其职、权责分明</a:t>
+              <a:t>6种固化角色，各司其职、权责分明</a:t>
             </a:r>
           </a:p>
         </p:txBody>
@@ -13321,7 +13321,7 @@
         </p:nvSpPr>
         <p:spPr>
           <a:xfrm>
-            <a:off x="3273552" y="1920240"/>
+            <a:off x="4251960" y="1920240"/>
             <a:ext cx="2697480" cy="2011680"/>
           </a:xfrm>
           <a:prstGeom prst="rect">
@@ -13364,7 +13364,7 @@
         </p:nvSpPr>
         <p:spPr>
           <a:xfrm>
-            <a:off x="3273552" y="1920240"/>
+            <a:off x="4251960" y="1920240"/>
             <a:ext cx="2697480" cy="54864"/>
           </a:xfrm>
           <a:prstGeom prst="rect">
@@ -13407,7 +13407,7 @@
         </p:nvSpPr>
         <p:spPr>
           <a:xfrm>
-            <a:off x="4279392" y="2148840"/>
+            <a:off x="5257800" y="2148840"/>
             <a:ext cx="640080" cy="640080"/>
           </a:xfrm>
           <a:prstGeom prst="ellipse">
@@ -13450,7 +13450,7 @@
         </p:nvSpPr>
         <p:spPr>
           <a:xfrm>
-            <a:off x="4279392" y="2286000"/>
+            <a:off x="5257800" y="2286000"/>
             <a:ext cx="640080" cy="274320"/>
           </a:xfrm>
           <a:prstGeom prst="rect">
@@ -13485,7 +13485,7 @@
         </p:nvSpPr>
         <p:spPr>
           <a:xfrm>
-            <a:off x="3410712" y="2926080"/>
+            <a:off x="4389120" y="2926080"/>
             <a:ext cx="2423160" cy="274320"/>
           </a:xfrm>
           <a:prstGeom prst="rect">
@@ -13520,7 +13520,7 @@
         </p:nvSpPr>
         <p:spPr>
           <a:xfrm>
-            <a:off x="3410712" y="3246120"/>
+            <a:off x="4389120" y="3246120"/>
             <a:ext cx="2423160" cy="548640"/>
           </a:xfrm>
           <a:prstGeom prst="rect">
@@ -13559,7 +13559,7 @@
         </p:nvSpPr>
         <p:spPr>
           <a:xfrm>
-            <a:off x="6181344" y="1920240"/>
+            <a:off x="8138160" y="1920240"/>
             <a:ext cx="2697480" cy="2011680"/>
           </a:xfrm>
           <a:prstGeom prst="rect">
@@ -13602,7 +13602,7 @@
         </p:nvSpPr>
         <p:spPr>
           <a:xfrm>
-            <a:off x="6181344" y="1920240"/>
+            <a:off x="8138160" y="1920240"/>
             <a:ext cx="2697480" cy="54864"/>
           </a:xfrm>
           <a:prstGeom prst="rect">
@@ -13645,7 +13645,7 @@
         </p:nvSpPr>
         <p:spPr>
           <a:xfrm>
-            <a:off x="7187184" y="2148840"/>
+            <a:off x="9144000" y="2148840"/>
             <a:ext cx="640080" cy="640080"/>
           </a:xfrm>
           <a:prstGeom prst="ellipse">
@@ -13688,7 +13688,7 @@
         </p:nvSpPr>
         <p:spPr>
           <a:xfrm>
-            <a:off x="7187184" y="2286000"/>
+            <a:off x="9144000" y="2286000"/>
             <a:ext cx="640080" cy="274320"/>
           </a:xfrm>
           <a:prstGeom prst="rect">
@@ -13723,7 +13723,7 @@
         </p:nvSpPr>
         <p:spPr>
           <a:xfrm>
-            <a:off x="6318504" y="2926080"/>
+            <a:off x="8275320" y="2926080"/>
             <a:ext cx="2423160" cy="274320"/>
           </a:xfrm>
           <a:prstGeom prst="rect">
@@ -13758,7 +13758,7 @@
         </p:nvSpPr>
         <p:spPr>
           <a:xfrm>
-            <a:off x="6318504" y="3246120"/>
+            <a:off x="8275320" y="3246120"/>
             <a:ext cx="2423160" cy="548640"/>
           </a:xfrm>
           <a:prstGeom prst="rect">
@@ -13797,7 +13797,7 @@
         </p:nvSpPr>
         <p:spPr>
           <a:xfrm>
-            <a:off x="9089136" y="1920240"/>
+            <a:off x="365760" y="4206240"/>
             <a:ext cx="2697480" cy="2011680"/>
           </a:xfrm>
           <a:prstGeom prst="rect">
@@ -13840,7 +13840,7 @@
         </p:nvSpPr>
         <p:spPr>
           <a:xfrm>
-            <a:off x="9089136" y="1920240"/>
+            <a:off x="365760" y="4206240"/>
             <a:ext cx="2697480" cy="54864"/>
           </a:xfrm>
           <a:prstGeom prst="rect">
@@ -13883,7 +13883,7 @@
         </p:nvSpPr>
         <p:spPr>
           <a:xfrm>
-            <a:off x="10094976" y="2148840"/>
+            <a:off x="1371600" y="4434840"/>
             <a:ext cx="640080" cy="640080"/>
           </a:xfrm>
           <a:prstGeom prst="ellipse">
@@ -13926,7 +13926,7 @@
         </p:nvSpPr>
         <p:spPr>
           <a:xfrm>
-            <a:off x="10094976" y="2286000"/>
+            <a:off x="1371600" y="4572000"/>
             <a:ext cx="640080" cy="274320"/>
           </a:xfrm>
           <a:prstGeom prst="rect">
@@ -13961,7 +13961,7 @@
         </p:nvSpPr>
         <p:spPr>
           <a:xfrm>
-            <a:off x="9226296" y="2926080"/>
+            <a:off x="502920" y="5212080"/>
             <a:ext cx="2423160" cy="274320"/>
           </a:xfrm>
           <a:prstGeom prst="rect">
@@ -13996,7 +13996,7 @@
         </p:nvSpPr>
         <p:spPr>
           <a:xfrm>
-            <a:off x="9226296" y="3246120"/>
+            <a:off x="502920" y="5532120"/>
             <a:ext cx="2423160" cy="548640"/>
           </a:xfrm>
           <a:prstGeom prst="rect">
@@ -14035,7 +14035,7 @@
         </p:nvSpPr>
         <p:spPr>
           <a:xfrm>
-            <a:off x="365760" y="4206240"/>
+            <a:off x="4251960" y="4206240"/>
             <a:ext cx="2697480" cy="2011680"/>
           </a:xfrm>
           <a:prstGeom prst="rect">
@@ -14078,7 +14078,7 @@
         </p:nvSpPr>
         <p:spPr>
           <a:xfrm>
-            <a:off x="365760" y="4206240"/>
+            <a:off x="4251960" y="4206240"/>
             <a:ext cx="2697480" cy="54864"/>
           </a:xfrm>
           <a:prstGeom prst="rect">
@@ -14121,7 +14121,7 @@
         </p:nvSpPr>
         <p:spPr>
           <a:xfrm>
-            <a:off x="1371600" y="4434840"/>
+            <a:off x="5257800" y="4434840"/>
             <a:ext cx="640080" cy="640080"/>
           </a:xfrm>
           <a:prstGeom prst="ellipse">
@@ -14164,7 +14164,7 @@
         </p:nvSpPr>
         <p:spPr>
           <a:xfrm>
-            <a:off x="1371600" y="4572000"/>
+            <a:off x="5257800" y="4572000"/>
             <a:ext cx="640080" cy="274320"/>
           </a:xfrm>
           <a:prstGeom prst="rect">
@@ -14199,7 +14199,7 @@
         </p:nvSpPr>
         <p:spPr>
           <a:xfrm>
-            <a:off x="502920" y="5212080"/>
+            <a:off x="4389120" y="5212080"/>
             <a:ext cx="2423160" cy="274320"/>
           </a:xfrm>
           <a:prstGeom prst="rect">
@@ -14234,7 +14234,7 @@
         </p:nvSpPr>
         <p:spPr>
           <a:xfrm>
-            <a:off x="502920" y="5532120"/>
+            <a:off x="4389120" y="5532120"/>
             <a:ext cx="2423160" cy="548640"/>
           </a:xfrm>
           <a:prstGeom prst="rect">
@@ -14273,7 +14273,7 @@
         </p:nvSpPr>
         <p:spPr>
           <a:xfrm>
-            <a:off x="3273552" y="4206240"/>
+            <a:off x="8138160" y="4206240"/>
             <a:ext cx="2697480" cy="2011680"/>
           </a:xfrm>
           <a:prstGeom prst="rect">
@@ -14316,7 +14316,7 @@
         </p:nvSpPr>
         <p:spPr>
           <a:xfrm>
-            <a:off x="3273552" y="4206240"/>
+            <a:off x="8138160" y="4206240"/>
             <a:ext cx="2697480" cy="54864"/>
           </a:xfrm>
           <a:prstGeom prst="rect">
@@ -14359,7 +14359,7 @@
         </p:nvSpPr>
         <p:spPr>
           <a:xfrm>
-            <a:off x="4279392" y="4434840"/>
+            <a:off x="9144000" y="4434840"/>
             <a:ext cx="640080" cy="640080"/>
           </a:xfrm>
           <a:prstGeom prst="ellipse">
@@ -14402,7 +14402,7 @@
         </p:nvSpPr>
         <p:spPr>
           <a:xfrm>
-            <a:off x="4279392" y="4572000"/>
+            <a:off x="9144000" y="4572000"/>
             <a:ext cx="640080" cy="274320"/>
           </a:xfrm>
           <a:prstGeom prst="rect">
@@ -14437,7 +14437,7 @@
         </p:nvSpPr>
         <p:spPr>
           <a:xfrm>
-            <a:off x="3410712" y="5212080"/>
+            <a:off x="8275320" y="5212080"/>
             <a:ext cx="2423160" cy="274320"/>
           </a:xfrm>
           <a:prstGeom prst="rect">
@@ -14472,7 +14472,7 @@
         </p:nvSpPr>
         <p:spPr>
           <a:xfrm>
-            <a:off x="3410712" y="5532120"/>
+            <a:off x="8275320" y="5532120"/>
             <a:ext cx="2423160" cy="548640"/>
           </a:xfrm>
           <a:prstGeom prst="rect">
@@ -14499,482 +14499,6 @@
             <a:br/>
             <a:r>
               <a:t>记录行程和里程信息</a:t>
-            </a:r>
-          </a:p>
-        </p:txBody>
-      </p:sp>
-      <p:sp>
-        <p:nvSpPr>
-          <p:cNvPr id="41" name="Rectangle 40"/>
-          <p:cNvSpPr/>
-          <p:nvPr/>
-        </p:nvSpPr>
-        <p:spPr>
-          <a:xfrm>
-            <a:off x="6181344" y="4206240"/>
-            <a:ext cx="2697480" cy="2011680"/>
-          </a:xfrm>
-          <a:prstGeom prst="rect">
-            <a:avLst/>
-          </a:prstGeom>
-          <a:solidFill>
-            <a:srgbClr val="FFFFFF"/>
-          </a:solidFill>
-          <a:ln>
-            <a:noFill/>
-          </a:ln>
-        </p:spPr>
-        <p:style>
-          <a:lnRef idx="1">
-            <a:schemeClr val="accent1"/>
-          </a:lnRef>
-          <a:fillRef idx="3">
-            <a:schemeClr val="accent1"/>
-          </a:fillRef>
-          <a:effectRef idx="2">
-            <a:schemeClr val="accent1"/>
-          </a:effectRef>
-          <a:fontRef idx="minor">
-            <a:schemeClr val="lt1"/>
-          </a:fontRef>
-        </p:style>
-        <p:txBody>
-          <a:bodyPr rtlCol="0" anchor="ctr"/>
-          <a:lstStyle/>
-          <a:p>
-            <a:pPr algn="ctr"/>
-          </a:p>
-        </p:txBody>
-      </p:sp>
-      <p:sp>
-        <p:nvSpPr>
-          <p:cNvPr id="42" name="Rectangle 41"/>
-          <p:cNvSpPr/>
-          <p:nvPr/>
-        </p:nvSpPr>
-        <p:spPr>
-          <a:xfrm>
-            <a:off x="6181344" y="4206240"/>
-            <a:ext cx="2697480" cy="54864"/>
-          </a:xfrm>
-          <a:prstGeom prst="rect">
-            <a:avLst/>
-          </a:prstGeom>
-          <a:solidFill>
-            <a:srgbClr val="E6A23C"/>
-          </a:solidFill>
-          <a:ln>
-            <a:noFill/>
-          </a:ln>
-        </p:spPr>
-        <p:style>
-          <a:lnRef idx="1">
-            <a:schemeClr val="accent1"/>
-          </a:lnRef>
-          <a:fillRef idx="3">
-            <a:schemeClr val="accent1"/>
-          </a:fillRef>
-          <a:effectRef idx="2">
-            <a:schemeClr val="accent1"/>
-          </a:effectRef>
-          <a:fontRef idx="minor">
-            <a:schemeClr val="lt1"/>
-          </a:fontRef>
-        </p:style>
-        <p:txBody>
-          <a:bodyPr rtlCol="0" anchor="ctr"/>
-          <a:lstStyle/>
-          <a:p>
-            <a:pPr algn="ctr"/>
-          </a:p>
-        </p:txBody>
-      </p:sp>
-      <p:sp>
-        <p:nvSpPr>
-          <p:cNvPr id="43" name="Oval 42"/>
-          <p:cNvSpPr/>
-          <p:nvPr/>
-        </p:nvSpPr>
-        <p:spPr>
-          <a:xfrm>
-            <a:off x="7187184" y="4434840"/>
-            <a:ext cx="640080" cy="640080"/>
-          </a:xfrm>
-          <a:prstGeom prst="ellipse">
-            <a:avLst/>
-          </a:prstGeom>
-          <a:solidFill>
-            <a:srgbClr val="E6A23C"/>
-          </a:solidFill>
-          <a:ln>
-            <a:noFill/>
-          </a:ln>
-        </p:spPr>
-        <p:style>
-          <a:lnRef idx="1">
-            <a:schemeClr val="accent1"/>
-          </a:lnRef>
-          <a:fillRef idx="3">
-            <a:schemeClr val="accent1"/>
-          </a:fillRef>
-          <a:effectRef idx="2">
-            <a:schemeClr val="accent1"/>
-          </a:effectRef>
-          <a:fontRef idx="minor">
-            <a:schemeClr val="lt1"/>
-          </a:fontRef>
-        </p:style>
-        <p:txBody>
-          <a:bodyPr rtlCol="0" anchor="ctr"/>
-          <a:lstStyle/>
-          <a:p>
-            <a:pPr algn="ctr"/>
-          </a:p>
-        </p:txBody>
-      </p:sp>
-      <p:sp>
-        <p:nvSpPr>
-          <p:cNvPr id="44" name="TextBox 43"/>
-          <p:cNvSpPr txBox="1"/>
-          <p:nvPr/>
-        </p:nvSpPr>
-        <p:spPr>
-          <a:xfrm>
-            <a:off x="7187184" y="4572000"/>
-            <a:ext cx="640080" cy="274320"/>
-          </a:xfrm>
-          <a:prstGeom prst="rect">
-            <a:avLst/>
-          </a:prstGeom>
-          <a:noFill/>
-        </p:spPr>
-        <p:txBody>
-          <a:bodyPr wrap="square">
-            <a:spAutoFit/>
-          </a:bodyPr>
-          <a:lstStyle/>
-          <a:p>
-            <a:pPr algn="ctr">
-              <a:defRPr sz="2000" b="1">
-                <a:solidFill>
-                  <a:srgbClr val="FFFFFF"/>
-                </a:solidFill>
-              </a:defRPr>
-            </a:pPr>
-            <a:r>
-              <a:t>纪</a:t>
-            </a:r>
-          </a:p>
-        </p:txBody>
-      </p:sp>
-      <p:sp>
-        <p:nvSpPr>
-          <p:cNvPr id="45" name="TextBox 44"/>
-          <p:cNvSpPr txBox="1"/>
-          <p:nvPr/>
-        </p:nvSpPr>
-        <p:spPr>
-          <a:xfrm>
-            <a:off x="6318504" y="5212080"/>
-            <a:ext cx="2423160" cy="274320"/>
-          </a:xfrm>
-          <a:prstGeom prst="rect">
-            <a:avLst/>
-          </a:prstGeom>
-          <a:noFill/>
-        </p:spPr>
-        <p:txBody>
-          <a:bodyPr wrap="square">
-            <a:spAutoFit/>
-          </a:bodyPr>
-          <a:lstStyle/>
-          <a:p>
-            <a:pPr algn="ctr">
-              <a:defRPr sz="1400" b="1">
-                <a:solidFill>
-                  <a:srgbClr val="1A3A6B"/>
-                </a:solidFill>
-              </a:defRPr>
-            </a:pPr>
-            <a:r>
-              <a:t>纪检监察人员</a:t>
-            </a:r>
-          </a:p>
-        </p:txBody>
-      </p:sp>
-      <p:sp>
-        <p:nvSpPr>
-          <p:cNvPr id="46" name="TextBox 45"/>
-          <p:cNvSpPr txBox="1"/>
-          <p:nvPr/>
-        </p:nvSpPr>
-        <p:spPr>
-          <a:xfrm>
-            <a:off x="6318504" y="5532120"/>
-            <a:ext cx="2423160" cy="548640"/>
-          </a:xfrm>
-          <a:prstGeom prst="rect">
-            <a:avLst/>
-          </a:prstGeom>
-          <a:noFill/>
-        </p:spPr>
-        <p:txBody>
-          <a:bodyPr wrap="square">
-            <a:spAutoFit/>
-          </a:bodyPr>
-          <a:lstStyle/>
-          <a:p>
-            <a:pPr algn="ctr">
-              <a:defRPr sz="1100" b="0">
-                <a:solidFill>
-                  <a:srgbClr val="666666"/>
-                </a:solidFill>
-              </a:defRPr>
-            </a:pPr>
-            <a:r>
-              <a:t>独立监督用车行为合规性，</a:t>
-            </a:r>
-            <a:br/>
-            <a:r>
-              <a:t>查看操作日志和审计记录</a:t>
-            </a:r>
-          </a:p>
-        </p:txBody>
-      </p:sp>
-      <p:sp>
-        <p:nvSpPr>
-          <p:cNvPr id="47" name="Rectangle 46"/>
-          <p:cNvSpPr/>
-          <p:nvPr/>
-        </p:nvSpPr>
-        <p:spPr>
-          <a:xfrm>
-            <a:off x="9089136" y="4206240"/>
-            <a:ext cx="2697480" cy="2011680"/>
-          </a:xfrm>
-          <a:prstGeom prst="rect">
-            <a:avLst/>
-          </a:prstGeom>
-          <a:solidFill>
-            <a:srgbClr val="FFFFFF"/>
-          </a:solidFill>
-          <a:ln>
-            <a:noFill/>
-          </a:ln>
-        </p:spPr>
-        <p:style>
-          <a:lnRef idx="1">
-            <a:schemeClr val="accent1"/>
-          </a:lnRef>
-          <a:fillRef idx="3">
-            <a:schemeClr val="accent1"/>
-          </a:fillRef>
-          <a:effectRef idx="2">
-            <a:schemeClr val="accent1"/>
-          </a:effectRef>
-          <a:fontRef idx="minor">
-            <a:schemeClr val="lt1"/>
-          </a:fontRef>
-        </p:style>
-        <p:txBody>
-          <a:bodyPr rtlCol="0" anchor="ctr"/>
-          <a:lstStyle/>
-          <a:p>
-            <a:pPr algn="ctr"/>
-          </a:p>
-        </p:txBody>
-      </p:sp>
-      <p:sp>
-        <p:nvSpPr>
-          <p:cNvPr id="48" name="Rectangle 47"/>
-          <p:cNvSpPr/>
-          <p:nvPr/>
-        </p:nvSpPr>
-        <p:spPr>
-          <a:xfrm>
-            <a:off x="9089136" y="4206240"/>
-            <a:ext cx="2697480" cy="54864"/>
-          </a:xfrm>
-          <a:prstGeom prst="rect">
-            <a:avLst/>
-          </a:prstGeom>
-          <a:solidFill>
-            <a:srgbClr val="C02828"/>
-          </a:solidFill>
-          <a:ln>
-            <a:noFill/>
-          </a:ln>
-        </p:spPr>
-        <p:style>
-          <a:lnRef idx="1">
-            <a:schemeClr val="accent1"/>
-          </a:lnRef>
-          <a:fillRef idx="3">
-            <a:schemeClr val="accent1"/>
-          </a:fillRef>
-          <a:effectRef idx="2">
-            <a:schemeClr val="accent1"/>
-          </a:effectRef>
-          <a:fontRef idx="minor">
-            <a:schemeClr val="lt1"/>
-          </a:fontRef>
-        </p:style>
-        <p:txBody>
-          <a:bodyPr rtlCol="0" anchor="ctr"/>
-          <a:lstStyle/>
-          <a:p>
-            <a:pPr algn="ctr"/>
-          </a:p>
-        </p:txBody>
-      </p:sp>
-      <p:sp>
-        <p:nvSpPr>
-          <p:cNvPr id="49" name="Oval 48"/>
-          <p:cNvSpPr/>
-          <p:nvPr/>
-        </p:nvSpPr>
-        <p:spPr>
-          <a:xfrm>
-            <a:off x="10094976" y="4434840"/>
-            <a:ext cx="640080" cy="640080"/>
-          </a:xfrm>
-          <a:prstGeom prst="ellipse">
-            <a:avLst/>
-          </a:prstGeom>
-          <a:solidFill>
-            <a:srgbClr val="C02828"/>
-          </a:solidFill>
-          <a:ln>
-            <a:noFill/>
-          </a:ln>
-        </p:spPr>
-        <p:style>
-          <a:lnRef idx="1">
-            <a:schemeClr val="accent1"/>
-          </a:lnRef>
-          <a:fillRef idx="3">
-            <a:schemeClr val="accent1"/>
-          </a:fillRef>
-          <a:effectRef idx="2">
-            <a:schemeClr val="accent1"/>
-          </a:effectRef>
-          <a:fontRef idx="minor">
-            <a:schemeClr val="lt1"/>
-          </a:fontRef>
-        </p:style>
-        <p:txBody>
-          <a:bodyPr rtlCol="0" anchor="ctr"/>
-          <a:lstStyle/>
-          <a:p>
-            <a:pPr algn="ctr"/>
-          </a:p>
-        </p:txBody>
-      </p:sp>
-      <p:sp>
-        <p:nvSpPr>
-          <p:cNvPr id="50" name="TextBox 49"/>
-          <p:cNvSpPr txBox="1"/>
-          <p:nvPr/>
-        </p:nvSpPr>
-        <p:spPr>
-          <a:xfrm>
-            <a:off x="10094976" y="4572000"/>
-            <a:ext cx="640080" cy="274320"/>
-          </a:xfrm>
-          <a:prstGeom prst="rect">
-            <a:avLst/>
-          </a:prstGeom>
-          <a:noFill/>
-        </p:spPr>
-        <p:txBody>
-          <a:bodyPr wrap="square">
-            <a:spAutoFit/>
-          </a:bodyPr>
-          <a:lstStyle/>
-          <a:p>
-            <a:pPr algn="ctr">
-              <a:defRPr sz="2000" b="1">
-                <a:solidFill>
-                  <a:srgbClr val="FFFFFF"/>
-                </a:solidFill>
-              </a:defRPr>
-            </a:pPr>
-            <a:r>
-              <a:t>财</a:t>
-            </a:r>
-          </a:p>
-        </p:txBody>
-      </p:sp>
-      <p:sp>
-        <p:nvSpPr>
-          <p:cNvPr id="51" name="TextBox 50"/>
-          <p:cNvSpPr txBox="1"/>
-          <p:nvPr/>
-        </p:nvSpPr>
-        <p:spPr>
-          <a:xfrm>
-            <a:off x="9226296" y="5212080"/>
-            <a:ext cx="2423160" cy="274320"/>
-          </a:xfrm>
-          <a:prstGeom prst="rect">
-            <a:avLst/>
-          </a:prstGeom>
-          <a:noFill/>
-        </p:spPr>
-        <p:txBody>
-          <a:bodyPr wrap="square">
-            <a:spAutoFit/>
-          </a:bodyPr>
-          <a:lstStyle/>
-          <a:p>
-            <a:pPr algn="ctr">
-              <a:defRPr sz="1400" b="1">
-                <a:solidFill>
-                  <a:srgbClr val="1A3A6B"/>
-                </a:solidFill>
-              </a:defRPr>
-            </a:pPr>
-            <a:r>
-              <a:t>财务人员</a:t>
-            </a:r>
-          </a:p>
-        </p:txBody>
-      </p:sp>
-      <p:sp>
-        <p:nvSpPr>
-          <p:cNvPr id="52" name="TextBox 51"/>
-          <p:cNvSpPr txBox="1"/>
-          <p:nvPr/>
-        </p:nvSpPr>
-        <p:spPr>
-          <a:xfrm>
-            <a:off x="9226296" y="5532120"/>
-            <a:ext cx="2423160" cy="548640"/>
-          </a:xfrm>
-          <a:prstGeom prst="rect">
-            <a:avLst/>
-          </a:prstGeom>
-          <a:noFill/>
-        </p:spPr>
-        <p:txBody>
-          <a:bodyPr wrap="square">
-            <a:spAutoFit/>
-          </a:bodyPr>
-          <a:lstStyle/>
-          <a:p>
-            <a:pPr algn="ctr">
-              <a:defRPr sz="1100" b="0">
-                <a:solidFill>
-                  <a:srgbClr val="666666"/>
-                </a:solidFill>
-              </a:defRPr>
-            </a:pPr>
-            <a:r>
-              <a:t>审核费用报销单据，</a:t>
-            </a:r>
-            <a:br/>
-            <a:r>
-              <a:t>管理预算执行和费用核算</a:t>
             </a:r>
           </a:p>
         </p:txBody>
@@ -17457,7 +16981,7 @@
               </a:defRPr>
             </a:pPr>
             <a:r>
-              <a:t>  实现8种角色的权限体系，完成用户导入和权限配置</a:t>
+              <a:t>  实现6种角色的权限体系，完成用户导入和权限配置</a:t>
             </a:r>
           </a:p>
         </p:txBody>

</xml_diff>